<commit_message>
Redesign: subtitle states the 60% to 97% spread, even notes column, period in source line
Co-Authored-By: Claude Opus 5.5 <noreply@anthropic.com>
Claude-Session: https://claude.ai/code/session_01QhAcegZCA84C1dHz9XeXfw
</commit_message>
<xml_diff>
--- a/slides/figure1/redesign.pptx
+++ b/slides/figure1/redesign.pptx
@@ -1418,7 +1418,7 @@
                 <a:ea typeface="Arial" pitchFamily="34" charset="-122"/>
                 <a:cs typeface="Arial" pitchFamily="34" charset="-120"/>
               </a:rPr>
-              <a:t>Agencies planned 79% of FY2025 IT spending, about $83 billion, for operations and maintenance</a:t>
+              <a:t>Agencies planned 79% of FY2025 IT spending, about $83 billion, for operations and maintenance (O&amp;M)</a:t>
             </a:r>
             <a:endParaRPr lang="en-US" sz="2800" dirty="0"/>
           </a:p>
@@ -1457,7 +1457,7 @@
                 <a:ea typeface="Arial" pitchFamily="34" charset="-122"/>
                 <a:cs typeface="Arial" pitchFamily="34" charset="-120"/>
               </a:rPr>
-              <a:t>Share of each agency's planned FY2025 IT spending that goes to operations and maintenance (O&amp;M)</a:t>
+              <a:t>Planned O&amp;M share by agency ranged from 60% (Transportation) to 97% (Housing and Urban Development)</a:t>
             </a:r>
             <a:endParaRPr lang="en-US" sz="1600" dirty="0"/>
           </a:p>
@@ -1550,7 +1550,7 @@
         <p:spPr>
           <a:xfrm>
             <a:off x="8732520" y="1938528"/>
-            <a:ext cx="3001975" cy="1234440"/>
+            <a:ext cx="3001975" cy="3931920"/>
           </a:xfrm>
           <a:prstGeom prst="rect">
             <a:avLst/>
@@ -1578,30 +1578,11 @@
             </a:r>
             <a:endParaRPr lang="en-US" sz="1400" dirty="0"/>
           </a:p>
-        </p:txBody>
-      </p:sp>
-      <p:sp>
-        <p:nvSpPr>
-          <p:cNvPr id="8" name="Text 5"/>
-          <p:cNvSpPr/>
-          <p:nvPr/>
-        </p:nvSpPr>
-        <p:spPr>
-          <a:xfrm>
-            <a:off x="8732520" y="3337560"/>
-            <a:ext cx="3001975" cy="1463040"/>
-          </a:xfrm>
-          <a:prstGeom prst="rect">
-            <a:avLst/>
-          </a:prstGeom>
-          <a:noFill/>
-          <a:ln/>
-        </p:spPr>
-        <p:txBody>
-          <a:bodyPr wrap="square" lIns="0" tIns="0" rIns="0" bIns="0" rtlCol="0" anchor="t"/>
-          <a:lstStyle/>
           <a:p>
             <a:pPr indent="0" marL="0">
+              <a:spcBef>
+                <a:spcPts val="2400"/>
+              </a:spcBef>
               <a:buNone/>
             </a:pPr>
             <a:r>
@@ -1617,30 +1598,11 @@
             </a:r>
             <a:endParaRPr lang="en-US" sz="1400" dirty="0"/>
           </a:p>
-        </p:txBody>
-      </p:sp>
-      <p:sp>
-        <p:nvSpPr>
-          <p:cNvPr id="9" name="Text 6"/>
-          <p:cNvSpPr/>
-          <p:nvPr/>
-        </p:nvSpPr>
-        <p:spPr>
-          <a:xfrm>
-            <a:off x="8732520" y="4892040"/>
-            <a:ext cx="3001975" cy="685800"/>
-          </a:xfrm>
-          <a:prstGeom prst="rect">
-            <a:avLst/>
-          </a:prstGeom>
-          <a:noFill/>
-          <a:ln/>
-        </p:spPr>
-        <p:txBody>
-          <a:bodyPr wrap="square" lIns="0" tIns="0" rIns="0" bIns="0" rtlCol="0" anchor="t"/>
-          <a:lstStyle/>
           <a:p>
             <a:pPr indent="0" marL="0">
+              <a:spcBef>
+                <a:spcPts val="2400"/>
+              </a:spcBef>
               <a:buNone/>
             </a:pPr>
             <a:r>
@@ -1660,7 +1622,7 @@
       </p:sp>
       <p:sp>
         <p:nvSpPr>
-          <p:cNvPr id="10" name="Text 7"/>
+          <p:cNvPr id="8" name="Text 5"/>
           <p:cNvSpPr/>
           <p:nvPr/>
         </p:nvSpPr>
@@ -1691,7 +1653,7 @@
                 <a:ea typeface="Arial" pitchFamily="34" charset="-122"/>
                 <a:cs typeface="Arial" pitchFamily="34" charset="-120"/>
               </a:rPr>
-              <a:t>Source: GAO-25-107795, Figure 1 (July 2025); GAO analysis of IT Dashboard data, 24 CFO Act agencies.</a:t>
+              <a:t>Source: GAO-25-107795, Figure 1 (July 2025). GAO analysis of IT Dashboard data for the 24 CFO Act agencies.</a:t>
             </a:r>
             <a:endParaRPr lang="en-US" sz="1000" dirty="0"/>
           </a:p>
@@ -1699,7 +1661,7 @@
       </p:sp>
       <p:sp>
         <p:nvSpPr>
-          <p:cNvPr id="11" name="Text 8"/>
+          <p:cNvPr id="9" name="Text 6"/>
           <p:cNvSpPr/>
           <p:nvPr/>
         </p:nvSpPr>
@@ -1787,7 +1749,7 @@
     </a:clrScheme>
     <a:fontScheme name="Office">
       <a:majorFont>
-        <a:latin typeface="Calibri Light" panose="020F0302020204030204"/>
+        <a:latin typeface="Arial"/>
         <a:ea typeface=""/>
         <a:cs typeface=""/>
         <a:font script="Jpan" typeface="游ゴシック Light"/>
@@ -1839,7 +1801,7 @@
         <a:font script="Tfng" typeface="Ebrima"/>
       </a:majorFont>
       <a:minorFont>
-        <a:latin typeface="Calibri" panose="020F0502020204030204"/>
+        <a:latin typeface="Arial"/>
         <a:ea typeface=""/>
         <a:cs typeface=""/>
         <a:font script="Jpan" typeface="游ゴシック"/>

</xml_diff>